<commit_message>
Add Chapter 2 & Lab 2
</commit_message>
<xml_diff>
--- a/static_files/laboratory/第一周：计算机网络实验课程介绍.pptx
+++ b/static_files/laboratory/第一周：计算机网络实验课程介绍.pptx
@@ -6431,7 +6431,7 @@
               <a:pPr>
                 <a:defRPr/>
               </a:pPr>
-              <a:t>2026/09/09</a:t>
+              <a:t>2026/09/16</a:t>
             </a:fld>
             <a:endParaRPr lang="en-US" altLang="zh-CN"/>
           </a:p>
@@ -11231,7 +11231,7 @@
             <a:fld id="{BB962C8B-B14F-4D97-AF65-F5344CB8AC3E}" type="datetime1">
               <a:rPr lang="zh-CN" altLang="en-US"/>
               <a:pPr/>
-              <a:t>2026/09/09</a:t>
+              <a:t>2026/09/16</a:t>
             </a:fld>
             <a:endParaRPr lang="zh-CN" altLang="en-US"/>
           </a:p>
@@ -11437,7 +11437,7 @@
             <a:fld id="{BB962C8B-B14F-4D97-AF65-F5344CB8AC3E}" type="datetime1">
               <a:rPr lang="zh-CN" altLang="en-US"/>
               <a:pPr/>
-              <a:t>2026/09/09</a:t>
+              <a:t>2026/09/16</a:t>
             </a:fld>
             <a:endParaRPr lang="zh-CN" altLang="en-US"/>
           </a:p>
@@ -11720,7 +11720,7 @@
             <a:fld id="{BB962C8B-B14F-4D97-AF65-F5344CB8AC3E}" type="datetime1">
               <a:rPr lang="zh-CN" altLang="en-US"/>
               <a:pPr/>
-              <a:t>2026/09/09</a:t>
+              <a:t>2026/09/16</a:t>
             </a:fld>
             <a:endParaRPr lang="zh-CN" altLang="en-US"/>
           </a:p>
@@ -11987,7 +11987,7 @@
             <a:fld id="{BB962C8B-B14F-4D97-AF65-F5344CB8AC3E}" type="datetime1">
               <a:rPr lang="zh-CN" altLang="en-US"/>
               <a:pPr/>
-              <a:t>2026/09/09</a:t>
+              <a:t>2026/09/16</a:t>
             </a:fld>
             <a:endParaRPr lang="zh-CN" altLang="en-US"/>
           </a:p>
@@ -12401,7 +12401,7 @@
             <a:fld id="{BB962C8B-B14F-4D97-AF65-F5344CB8AC3E}" type="datetime1">
               <a:rPr lang="zh-CN" altLang="en-US"/>
               <a:pPr/>
-              <a:t>2026/09/09</a:t>
+              <a:t>2026/09/16</a:t>
             </a:fld>
             <a:endParaRPr lang="zh-CN" altLang="en-US"/>
           </a:p>
@@ -12556,7 +12556,7 @@
             <a:fld id="{BB962C8B-B14F-4D97-AF65-F5344CB8AC3E}" type="datetime1">
               <a:rPr lang="zh-CN" altLang="en-US"/>
               <a:pPr/>
-              <a:t>2026/09/09</a:t>
+              <a:t>2026/09/16</a:t>
             </a:fld>
             <a:endParaRPr lang="zh-CN" altLang="en-US"/>
           </a:p>
@@ -12995,7 +12995,7 @@
             <a:fld id="{BB962C8B-B14F-4D97-AF65-F5344CB8AC3E}" type="datetime1">
               <a:rPr lang="zh-CN" altLang="en-US"/>
               <a:pPr/>
-              <a:t>2026/09/09</a:t>
+              <a:t>2026/09/16</a:t>
             </a:fld>
             <a:endParaRPr lang="zh-CN" altLang="en-US"/>
           </a:p>
@@ -13308,7 +13308,7 @@
             <a:fld id="{BB962C8B-B14F-4D97-AF65-F5344CB8AC3E}" type="datetime1">
               <a:rPr lang="zh-CN" altLang="en-US"/>
               <a:pPr/>
-              <a:t>2026/09/09</a:t>
+              <a:t>2026/09/16</a:t>
             </a:fld>
             <a:endParaRPr lang="zh-CN" altLang="en-US"/>
           </a:p>
@@ -13602,7 +13602,7 @@
             <a:fld id="{BB962C8B-B14F-4D97-AF65-F5344CB8AC3E}" type="datetime1">
               <a:rPr lang="zh-CN" altLang="en-US"/>
               <a:pPr/>
-              <a:t>2026/09/09</a:t>
+              <a:t>2026/09/16</a:t>
             </a:fld>
             <a:endParaRPr lang="zh-CN" altLang="en-US"/>
           </a:p>
@@ -13808,7 +13808,7 @@
             <a:fld id="{BB962C8B-B14F-4D97-AF65-F5344CB8AC3E}" type="datetime1">
               <a:rPr lang="zh-CN" altLang="en-US"/>
               <a:pPr/>
-              <a:t>2026/09/09</a:t>
+              <a:t>2026/09/16</a:t>
             </a:fld>
             <a:endParaRPr lang="zh-CN" altLang="en-US"/>
           </a:p>
@@ -14024,7 +14024,7 @@
             <a:fld id="{BB962C8B-B14F-4D97-AF65-F5344CB8AC3E}" type="datetime1">
               <a:rPr lang="zh-CN" altLang="en-US"/>
               <a:pPr/>
-              <a:t>2026/09/09</a:t>
+              <a:t>2026/09/16</a:t>
             </a:fld>
             <a:endParaRPr lang="zh-CN" altLang="en-US"/>
           </a:p>
@@ -14291,7 +14291,7 @@
             <a:fld id="{BB962C8B-B14F-4D97-AF65-F5344CB8AC3E}" type="datetime1">
               <a:rPr lang="zh-CN" altLang="en-US"/>
               <a:pPr/>
-              <a:t>2026/09/09</a:t>
+              <a:t>2026/09/16</a:t>
             </a:fld>
             <a:endParaRPr lang="zh-CN" altLang="en-US"/>
           </a:p>
@@ -24511,7 +24511,7 @@
               <a:pPr>
                 <a:defRPr/>
               </a:pPr>
-              <a:t>9/9/2026</a:t>
+              <a:t>9/16/2026</a:t>
             </a:fld>
             <a:endParaRPr lang="en-US" dirty="0"/>
           </a:p>
@@ -25308,7 +25308,7 @@
             <a:fld id="{BB962C8B-B14F-4D97-AF65-F5344CB8AC3E}" type="datetime1">
               <a:rPr lang="zh-CN" altLang="en-US"/>
               <a:pPr/>
-              <a:t>2026/09/09</a:t>
+              <a:t>2026/09/16</a:t>
             </a:fld>
             <a:endParaRPr lang="zh-CN" altLang="en-US">
               <a:cs typeface="+mn-cs"/>
@@ -30812,7 +30812,7 @@
             </a:r>
             <a:r>
               <a:rPr lang="en-US" altLang="zh-CN" sz="2800" dirty="0"/>
-              <a:t>10:30-12:10</a:t>
+              <a:t>10:10-11:50</a:t>
             </a:r>
           </a:p>
           <a:p>
@@ -30823,15 +30823,7 @@
             </a:pPr>
             <a:r>
               <a:rPr lang="zh-CN" altLang="en-US" sz="2800" dirty="0"/>
-              <a:t>实验室开放时间：周一至周日，晚上</a:t>
-            </a:r>
-            <a:r>
-              <a:rPr lang="en-US" altLang="zh-CN" sz="2800" dirty="0"/>
-              <a:t>10:00</a:t>
-            </a:r>
-            <a:r>
-              <a:rPr lang="zh-CN" altLang="en-US" sz="2800" dirty="0"/>
-              <a:t>前</a:t>
+              <a:t>实验室开放时间：周一至周五，上班时间</a:t>
             </a:r>
           </a:p>
           <a:p>

</xml_diff>